<commit_message>
refactor: remove PowerPoint generation script and unused presentation assets
</commit_message>
<xml_diff>
--- a/sentryswarm_pitch.pptx
+++ b/sentryswarm_pitch.pptx
@@ -5,13 +5,13 @@
     <p:sldMasterId id="2147483648" r:id="rId1"/>
   </p:sldMasterIdLst>
   <p:sldIdLst>
-    <p:sldId id="256" r:id="rId7"/>
-    <p:sldId id="257" r:id="rId8"/>
-    <p:sldId id="258" r:id="rId9"/>
-    <p:sldId id="259" r:id="rId10"/>
-    <p:sldId id="260" r:id="rId11"/>
+    <p:sldId id="256" r:id="rId2"/>
+    <p:sldId id="257" r:id="rId3"/>
+    <p:sldId id="258" r:id="rId4"/>
+    <p:sldId id="259" r:id="rId5"/>
+    <p:sldId id="260" r:id="rId6"/>
   </p:sldIdLst>
-  <p:sldSz cx="12191695" cy="6858000" type="screen4x3"/>
+  <p:sldSz cx="12192000" cy="6858000"/>
   <p:notesSz cx="6858000" cy="9144000"/>
   <p:defaultTextStyle>
     <a:defPPr>
@@ -108,6 +108,22 @@
       </a:defRPr>
     </a:lvl9pPr>
   </p:defaultTextStyle>
+  <p:extLst>
+    <p:ext uri="{EFAFB233-063F-42B5-8137-9DF3F51BA10A}">
+      <p15:sldGuideLst xmlns:p15="http://schemas.microsoft.com/office/powerpoint/2012/main">
+        <p15:guide id="1" orient="horz" pos="2160">
+          <p15:clr>
+            <a:srgbClr val="A4A3A4"/>
+          </p15:clr>
+        </p15:guide>
+        <p15:guide id="2" pos="2880">
+          <p15:clr>
+            <a:srgbClr val="A4A3A4"/>
+          </p15:clr>
+        </p15:guide>
+      </p15:sldGuideLst>
+    </p:ext>
+  </p:extLst>
 </p:presentation>
 </file>
 
@@ -149,10 +165,9 @@
           <a:lstStyle/>
           <a:p>
             <a:r>
-              <a:rPr lang="en-US" smtClean="0"/>
+              <a:rPr lang="en-US"/>
               <a:t>Click to edit Master title style</a:t>
             </a:r>
-            <a:endParaRPr lang="en-US"/>
           </a:p>
         </p:txBody>
       </p:sp>
@@ -268,10 +283,9 @@
           </a:lstStyle>
           <a:p>
             <a:r>
-              <a:rPr lang="en-US" smtClean="0"/>
+              <a:rPr lang="en-US"/>
               <a:t>Click to edit Master subtitle style</a:t>
             </a:r>
-            <a:endParaRPr lang="en-US"/>
           </a:p>
         </p:txBody>
       </p:sp>
@@ -292,7 +306,7 @@
           <a:p>
             <a:fld id="{5BCAD085-E8A6-8845-BD4E-CB4CCA059FC4}" type="datetimeFigureOut">
               <a:rPr lang="en-US" smtClean="0"/>
-              <a:t>1/27/13</a:t>
+              <a:t>6/14/2026</a:t>
             </a:fld>
             <a:endParaRPr lang="en-US"/>
           </a:p>
@@ -386,10 +400,9 @@
           <a:lstStyle/>
           <a:p>
             <a:r>
-              <a:rPr lang="en-US" smtClean="0"/>
+              <a:rPr lang="en-US"/>
               <a:t>Click to edit Master title style</a:t>
             </a:r>
-            <a:endParaRPr lang="en-US"/>
           </a:p>
         </p:txBody>
       </p:sp>
@@ -410,38 +423,37 @@
           <a:p>
             <a:pPr lvl="0"/>
             <a:r>
-              <a:rPr lang="en-US" smtClean="0"/>
+              <a:rPr lang="en-US"/>
               <a:t>Click to edit Master text styles</a:t>
             </a:r>
           </a:p>
           <a:p>
             <a:pPr lvl="1"/>
             <a:r>
-              <a:rPr lang="en-US" smtClean="0"/>
+              <a:rPr lang="en-US"/>
               <a:t>Second level</a:t>
             </a:r>
           </a:p>
           <a:p>
             <a:pPr lvl="2"/>
             <a:r>
-              <a:rPr lang="en-US" smtClean="0"/>
+              <a:rPr lang="en-US"/>
               <a:t>Third level</a:t>
             </a:r>
           </a:p>
           <a:p>
             <a:pPr lvl="3"/>
             <a:r>
-              <a:rPr lang="en-US" smtClean="0"/>
+              <a:rPr lang="en-US"/>
               <a:t>Fourth level</a:t>
             </a:r>
           </a:p>
           <a:p>
             <a:pPr lvl="4"/>
             <a:r>
-              <a:rPr lang="en-US" smtClean="0"/>
+              <a:rPr lang="en-US"/>
               <a:t>Fifth level</a:t>
             </a:r>
-            <a:endParaRPr lang="en-US"/>
           </a:p>
         </p:txBody>
       </p:sp>
@@ -462,7 +474,7 @@
           <a:p>
             <a:fld id="{5BCAD085-E8A6-8845-BD4E-CB4CCA059FC4}" type="datetimeFigureOut">
               <a:rPr lang="en-US" smtClean="0"/>
-              <a:t>1/27/13</a:t>
+              <a:t>6/14/2026</a:t>
             </a:fld>
             <a:endParaRPr lang="en-US"/>
           </a:p>
@@ -561,10 +573,9 @@
           <a:lstStyle/>
           <a:p>
             <a:r>
-              <a:rPr lang="en-US" smtClean="0"/>
+              <a:rPr lang="en-US"/>
               <a:t>Click to edit Master title style</a:t>
             </a:r>
-            <a:endParaRPr lang="en-US"/>
           </a:p>
         </p:txBody>
       </p:sp>
@@ -590,38 +601,37 @@
           <a:p>
             <a:pPr lvl="0"/>
             <a:r>
-              <a:rPr lang="en-US" smtClean="0"/>
+              <a:rPr lang="en-US"/>
               <a:t>Click to edit Master text styles</a:t>
             </a:r>
           </a:p>
           <a:p>
             <a:pPr lvl="1"/>
             <a:r>
-              <a:rPr lang="en-US" smtClean="0"/>
+              <a:rPr lang="en-US"/>
               <a:t>Second level</a:t>
             </a:r>
           </a:p>
           <a:p>
             <a:pPr lvl="2"/>
             <a:r>
-              <a:rPr lang="en-US" smtClean="0"/>
+              <a:rPr lang="en-US"/>
               <a:t>Third level</a:t>
             </a:r>
           </a:p>
           <a:p>
             <a:pPr lvl="3"/>
             <a:r>
-              <a:rPr lang="en-US" smtClean="0"/>
+              <a:rPr lang="en-US"/>
               <a:t>Fourth level</a:t>
             </a:r>
           </a:p>
           <a:p>
             <a:pPr lvl="4"/>
             <a:r>
-              <a:rPr lang="en-US" smtClean="0"/>
+              <a:rPr lang="en-US"/>
               <a:t>Fifth level</a:t>
             </a:r>
-            <a:endParaRPr lang="en-US"/>
           </a:p>
         </p:txBody>
       </p:sp>
@@ -642,7 +652,7 @@
           <a:p>
             <a:fld id="{5BCAD085-E8A6-8845-BD4E-CB4CCA059FC4}" type="datetimeFigureOut">
               <a:rPr lang="en-US" smtClean="0"/>
-              <a:t>1/27/13</a:t>
+              <a:t>6/14/2026</a:t>
             </a:fld>
             <a:endParaRPr lang="en-US"/>
           </a:p>
@@ -736,10 +746,9 @@
           <a:lstStyle/>
           <a:p>
             <a:r>
-              <a:rPr lang="en-US" smtClean="0"/>
+              <a:rPr lang="en-US"/>
               <a:t>Click to edit Master title style</a:t>
             </a:r>
-            <a:endParaRPr lang="en-US"/>
           </a:p>
         </p:txBody>
       </p:sp>
@@ -760,38 +769,37 @@
           <a:p>
             <a:pPr lvl="0"/>
             <a:r>
-              <a:rPr lang="en-US" smtClean="0"/>
+              <a:rPr lang="en-US"/>
               <a:t>Click to edit Master text styles</a:t>
             </a:r>
           </a:p>
           <a:p>
             <a:pPr lvl="1"/>
             <a:r>
-              <a:rPr lang="en-US" smtClean="0"/>
+              <a:rPr lang="en-US"/>
               <a:t>Second level</a:t>
             </a:r>
           </a:p>
           <a:p>
             <a:pPr lvl="2"/>
             <a:r>
-              <a:rPr lang="en-US" smtClean="0"/>
+              <a:rPr lang="en-US"/>
               <a:t>Third level</a:t>
             </a:r>
           </a:p>
           <a:p>
             <a:pPr lvl="3"/>
             <a:r>
-              <a:rPr lang="en-US" smtClean="0"/>
+              <a:rPr lang="en-US"/>
               <a:t>Fourth level</a:t>
             </a:r>
           </a:p>
           <a:p>
             <a:pPr lvl="4"/>
             <a:r>
-              <a:rPr lang="en-US" smtClean="0"/>
+              <a:rPr lang="en-US"/>
               <a:t>Fifth level</a:t>
             </a:r>
-            <a:endParaRPr lang="en-US"/>
           </a:p>
         </p:txBody>
       </p:sp>
@@ -812,7 +820,7 @@
           <a:p>
             <a:fld id="{5BCAD085-E8A6-8845-BD4E-CB4CCA059FC4}" type="datetimeFigureOut">
               <a:rPr lang="en-US" smtClean="0"/>
-              <a:t>1/27/13</a:t>
+              <a:t>6/14/2026</a:t>
             </a:fld>
             <a:endParaRPr lang="en-US"/>
           </a:p>
@@ -915,10 +923,9 @@
           </a:lstStyle>
           <a:p>
             <a:r>
-              <a:rPr lang="en-US" smtClean="0"/>
+              <a:rPr lang="en-US"/>
               <a:t>Click to edit Master title style</a:t>
             </a:r>
-            <a:endParaRPr lang="en-US"/>
           </a:p>
         </p:txBody>
       </p:sp>
@@ -1035,7 +1042,7 @@
           <a:p>
             <a:pPr lvl="0"/>
             <a:r>
-              <a:rPr lang="en-US" smtClean="0"/>
+              <a:rPr lang="en-US"/>
               <a:t>Click to edit Master text styles</a:t>
             </a:r>
           </a:p>
@@ -1058,7 +1065,7 @@
           <a:p>
             <a:fld id="{5BCAD085-E8A6-8845-BD4E-CB4CCA059FC4}" type="datetimeFigureOut">
               <a:rPr lang="en-US" smtClean="0"/>
-              <a:t>1/27/13</a:t>
+              <a:t>6/14/2026</a:t>
             </a:fld>
             <a:endParaRPr lang="en-US"/>
           </a:p>
@@ -1152,10 +1159,9 @@
           <a:lstStyle/>
           <a:p>
             <a:r>
-              <a:rPr lang="en-US" smtClean="0"/>
+              <a:rPr lang="en-US"/>
               <a:t>Click to edit Master title style</a:t>
             </a:r>
-            <a:endParaRPr lang="en-US"/>
           </a:p>
         </p:txBody>
       </p:sp>
@@ -1209,38 +1215,37 @@
           <a:p>
             <a:pPr lvl="0"/>
             <a:r>
-              <a:rPr lang="en-US" smtClean="0"/>
+              <a:rPr lang="en-US"/>
               <a:t>Click to edit Master text styles</a:t>
             </a:r>
           </a:p>
           <a:p>
             <a:pPr lvl="1"/>
             <a:r>
-              <a:rPr lang="en-US" smtClean="0"/>
+              <a:rPr lang="en-US"/>
               <a:t>Second level</a:t>
             </a:r>
           </a:p>
           <a:p>
             <a:pPr lvl="2"/>
             <a:r>
-              <a:rPr lang="en-US" smtClean="0"/>
+              <a:rPr lang="en-US"/>
               <a:t>Third level</a:t>
             </a:r>
           </a:p>
           <a:p>
             <a:pPr lvl="3"/>
             <a:r>
-              <a:rPr lang="en-US" smtClean="0"/>
+              <a:rPr lang="en-US"/>
               <a:t>Fourth level</a:t>
             </a:r>
           </a:p>
           <a:p>
             <a:pPr lvl="4"/>
             <a:r>
-              <a:rPr lang="en-US" smtClean="0"/>
+              <a:rPr lang="en-US"/>
               <a:t>Fifth level</a:t>
             </a:r>
-            <a:endParaRPr lang="en-US"/>
           </a:p>
         </p:txBody>
       </p:sp>
@@ -1294,38 +1299,37 @@
           <a:p>
             <a:pPr lvl="0"/>
             <a:r>
-              <a:rPr lang="en-US" smtClean="0"/>
+              <a:rPr lang="en-US"/>
               <a:t>Click to edit Master text styles</a:t>
             </a:r>
           </a:p>
           <a:p>
             <a:pPr lvl="1"/>
             <a:r>
-              <a:rPr lang="en-US" smtClean="0"/>
+              <a:rPr lang="en-US"/>
               <a:t>Second level</a:t>
             </a:r>
           </a:p>
           <a:p>
             <a:pPr lvl="2"/>
             <a:r>
-              <a:rPr lang="en-US" smtClean="0"/>
+              <a:rPr lang="en-US"/>
               <a:t>Third level</a:t>
             </a:r>
           </a:p>
           <a:p>
             <a:pPr lvl="3"/>
             <a:r>
-              <a:rPr lang="en-US" smtClean="0"/>
+              <a:rPr lang="en-US"/>
               <a:t>Fourth level</a:t>
             </a:r>
           </a:p>
           <a:p>
             <a:pPr lvl="4"/>
             <a:r>
-              <a:rPr lang="en-US" smtClean="0"/>
+              <a:rPr lang="en-US"/>
               <a:t>Fifth level</a:t>
             </a:r>
-            <a:endParaRPr lang="en-US"/>
           </a:p>
         </p:txBody>
       </p:sp>
@@ -1346,7 +1350,7 @@
           <a:p>
             <a:fld id="{5BCAD085-E8A6-8845-BD4E-CB4CCA059FC4}" type="datetimeFigureOut">
               <a:rPr lang="en-US" smtClean="0"/>
-              <a:t>1/27/13</a:t>
+              <a:t>6/14/2026</a:t>
             </a:fld>
             <a:endParaRPr lang="en-US"/>
           </a:p>
@@ -1444,10 +1448,9 @@
           </a:lstStyle>
           <a:p>
             <a:r>
-              <a:rPr lang="en-US" smtClean="0"/>
+              <a:rPr lang="en-US"/>
               <a:t>Click to edit Master title style</a:t>
             </a:r>
-            <a:endParaRPr lang="en-US"/>
           </a:p>
         </p:txBody>
       </p:sp>
@@ -1510,7 +1513,7 @@
           <a:p>
             <a:pPr lvl="0"/>
             <a:r>
-              <a:rPr lang="en-US" smtClean="0"/>
+              <a:rPr lang="en-US"/>
               <a:t>Click to edit Master text styles</a:t>
             </a:r>
           </a:p>
@@ -1566,38 +1569,37 @@
           <a:p>
             <a:pPr lvl="0"/>
             <a:r>
-              <a:rPr lang="en-US" smtClean="0"/>
+              <a:rPr lang="en-US"/>
               <a:t>Click to edit Master text styles</a:t>
             </a:r>
           </a:p>
           <a:p>
             <a:pPr lvl="1"/>
             <a:r>
-              <a:rPr lang="en-US" smtClean="0"/>
+              <a:rPr lang="en-US"/>
               <a:t>Second level</a:t>
             </a:r>
           </a:p>
           <a:p>
             <a:pPr lvl="2"/>
             <a:r>
-              <a:rPr lang="en-US" smtClean="0"/>
+              <a:rPr lang="en-US"/>
               <a:t>Third level</a:t>
             </a:r>
           </a:p>
           <a:p>
             <a:pPr lvl="3"/>
             <a:r>
-              <a:rPr lang="en-US" smtClean="0"/>
+              <a:rPr lang="en-US"/>
               <a:t>Fourth level</a:t>
             </a:r>
           </a:p>
           <a:p>
             <a:pPr lvl="4"/>
             <a:r>
-              <a:rPr lang="en-US" smtClean="0"/>
+              <a:rPr lang="en-US"/>
               <a:t>Fifth level</a:t>
             </a:r>
-            <a:endParaRPr lang="en-US"/>
           </a:p>
         </p:txBody>
       </p:sp>
@@ -1660,7 +1662,7 @@
           <a:p>
             <a:pPr lvl="0"/>
             <a:r>
-              <a:rPr lang="en-US" smtClean="0"/>
+              <a:rPr lang="en-US"/>
               <a:t>Click to edit Master text styles</a:t>
             </a:r>
           </a:p>
@@ -1716,38 +1718,37 @@
           <a:p>
             <a:pPr lvl="0"/>
             <a:r>
-              <a:rPr lang="en-US" smtClean="0"/>
+              <a:rPr lang="en-US"/>
               <a:t>Click to edit Master text styles</a:t>
             </a:r>
           </a:p>
           <a:p>
             <a:pPr lvl="1"/>
             <a:r>
-              <a:rPr lang="en-US" smtClean="0"/>
+              <a:rPr lang="en-US"/>
               <a:t>Second level</a:t>
             </a:r>
           </a:p>
           <a:p>
             <a:pPr lvl="2"/>
             <a:r>
-              <a:rPr lang="en-US" smtClean="0"/>
+              <a:rPr lang="en-US"/>
               <a:t>Third level</a:t>
             </a:r>
           </a:p>
           <a:p>
             <a:pPr lvl="3"/>
             <a:r>
-              <a:rPr lang="en-US" smtClean="0"/>
+              <a:rPr lang="en-US"/>
               <a:t>Fourth level</a:t>
             </a:r>
           </a:p>
           <a:p>
             <a:pPr lvl="4"/>
             <a:r>
-              <a:rPr lang="en-US" smtClean="0"/>
+              <a:rPr lang="en-US"/>
               <a:t>Fifth level</a:t>
             </a:r>
-            <a:endParaRPr lang="en-US"/>
           </a:p>
         </p:txBody>
       </p:sp>
@@ -1768,7 +1769,7 @@
           <a:p>
             <a:fld id="{5BCAD085-E8A6-8845-BD4E-CB4CCA059FC4}" type="datetimeFigureOut">
               <a:rPr lang="en-US" smtClean="0"/>
-              <a:t>1/27/13</a:t>
+              <a:t>6/14/2026</a:t>
             </a:fld>
             <a:endParaRPr lang="en-US"/>
           </a:p>
@@ -1862,10 +1863,9 @@
           <a:lstStyle/>
           <a:p>
             <a:r>
-              <a:rPr lang="en-US" smtClean="0"/>
+              <a:rPr lang="en-US"/>
               <a:t>Click to edit Master title style</a:t>
             </a:r>
-            <a:endParaRPr lang="en-US"/>
           </a:p>
         </p:txBody>
       </p:sp>
@@ -1886,7 +1886,7 @@
           <a:p>
             <a:fld id="{5BCAD085-E8A6-8845-BD4E-CB4CCA059FC4}" type="datetimeFigureOut">
               <a:rPr lang="en-US" smtClean="0"/>
-              <a:t>1/27/13</a:t>
+              <a:t>6/14/2026</a:t>
             </a:fld>
             <a:endParaRPr lang="en-US"/>
           </a:p>
@@ -1981,7 +1981,7 @@
           <a:p>
             <a:fld id="{5BCAD085-E8A6-8845-BD4E-CB4CCA059FC4}" type="datetimeFigureOut">
               <a:rPr lang="en-US" smtClean="0"/>
-              <a:t>1/27/13</a:t>
+              <a:t>6/14/2026</a:t>
             </a:fld>
             <a:endParaRPr lang="en-US"/>
           </a:p>
@@ -2084,10 +2084,9 @@
           </a:lstStyle>
           <a:p>
             <a:r>
-              <a:rPr lang="en-US" smtClean="0"/>
+              <a:rPr lang="en-US"/>
               <a:t>Click to edit Master title style</a:t>
             </a:r>
-            <a:endParaRPr lang="en-US"/>
           </a:p>
         </p:txBody>
       </p:sp>
@@ -2141,38 +2140,37 @@
           <a:p>
             <a:pPr lvl="0"/>
             <a:r>
-              <a:rPr lang="en-US" smtClean="0"/>
+              <a:rPr lang="en-US"/>
               <a:t>Click to edit Master text styles</a:t>
             </a:r>
           </a:p>
           <a:p>
             <a:pPr lvl="1"/>
             <a:r>
-              <a:rPr lang="en-US" smtClean="0"/>
+              <a:rPr lang="en-US"/>
               <a:t>Second level</a:t>
             </a:r>
           </a:p>
           <a:p>
             <a:pPr lvl="2"/>
             <a:r>
-              <a:rPr lang="en-US" smtClean="0"/>
+              <a:rPr lang="en-US"/>
               <a:t>Third level</a:t>
             </a:r>
           </a:p>
           <a:p>
             <a:pPr lvl="3"/>
             <a:r>
-              <a:rPr lang="en-US" smtClean="0"/>
+              <a:rPr lang="en-US"/>
               <a:t>Fourth level</a:t>
             </a:r>
           </a:p>
           <a:p>
             <a:pPr lvl="4"/>
             <a:r>
-              <a:rPr lang="en-US" smtClean="0"/>
+              <a:rPr lang="en-US"/>
               <a:t>Fifth level</a:t>
             </a:r>
-            <a:endParaRPr lang="en-US"/>
           </a:p>
         </p:txBody>
       </p:sp>
@@ -2235,7 +2233,7 @@
           <a:p>
             <a:pPr lvl="0"/>
             <a:r>
-              <a:rPr lang="en-US" smtClean="0"/>
+              <a:rPr lang="en-US"/>
               <a:t>Click to edit Master text styles</a:t>
             </a:r>
           </a:p>
@@ -2258,7 +2256,7 @@
           <a:p>
             <a:fld id="{5BCAD085-E8A6-8845-BD4E-CB4CCA059FC4}" type="datetimeFigureOut">
               <a:rPr lang="en-US" smtClean="0"/>
-              <a:t>1/27/13</a:t>
+              <a:t>6/14/2026</a:t>
             </a:fld>
             <a:endParaRPr lang="en-US"/>
           </a:p>
@@ -2361,10 +2359,9 @@
           </a:lstStyle>
           <a:p>
             <a:r>
-              <a:rPr lang="en-US" smtClean="0"/>
+              <a:rPr lang="en-US"/>
               <a:t>Click to edit Master title style</a:t>
             </a:r>
-            <a:endParaRPr lang="en-US"/>
           </a:p>
         </p:txBody>
       </p:sp>
@@ -2488,7 +2485,7 @@
           <a:p>
             <a:pPr lvl="0"/>
             <a:r>
-              <a:rPr lang="en-US" smtClean="0"/>
+              <a:rPr lang="en-US"/>
               <a:t>Click to edit Master text styles</a:t>
             </a:r>
           </a:p>
@@ -2511,7 +2508,7 @@
           <a:p>
             <a:fld id="{5BCAD085-E8A6-8845-BD4E-CB4CCA059FC4}" type="datetimeFigureOut">
               <a:rPr lang="en-US" smtClean="0"/>
-              <a:t>1/27/13</a:t>
+              <a:t>6/14/2026</a:t>
             </a:fld>
             <a:endParaRPr lang="en-US"/>
           </a:p>
@@ -2620,10 +2617,9 @@
           <a:lstStyle/>
           <a:p>
             <a:r>
-              <a:rPr lang="en-US" smtClean="0"/>
+              <a:rPr lang="en-US"/>
               <a:t>Click to edit Master title style</a:t>
             </a:r>
-            <a:endParaRPr lang="en-US"/>
           </a:p>
         </p:txBody>
       </p:sp>
@@ -2654,38 +2650,37 @@
           <a:p>
             <a:pPr lvl="0"/>
             <a:r>
-              <a:rPr lang="en-US" smtClean="0"/>
+              <a:rPr lang="en-US"/>
               <a:t>Click to edit Master text styles</a:t>
             </a:r>
           </a:p>
           <a:p>
             <a:pPr lvl="1"/>
             <a:r>
-              <a:rPr lang="en-US" smtClean="0"/>
+              <a:rPr lang="en-US"/>
               <a:t>Second level</a:t>
             </a:r>
           </a:p>
           <a:p>
             <a:pPr lvl="2"/>
             <a:r>
-              <a:rPr lang="en-US" smtClean="0"/>
+              <a:rPr lang="en-US"/>
               <a:t>Third level</a:t>
             </a:r>
           </a:p>
           <a:p>
             <a:pPr lvl="3"/>
             <a:r>
-              <a:rPr lang="en-US" smtClean="0"/>
+              <a:rPr lang="en-US"/>
               <a:t>Fourth level</a:t>
             </a:r>
           </a:p>
           <a:p>
             <a:pPr lvl="4"/>
             <a:r>
-              <a:rPr lang="en-US" smtClean="0"/>
+              <a:rPr lang="en-US"/>
               <a:t>Fifth level</a:t>
             </a:r>
-            <a:endParaRPr lang="en-US"/>
           </a:p>
         </p:txBody>
       </p:sp>
@@ -2724,7 +2719,7 @@
           <a:p>
             <a:fld id="{5BCAD085-E8A6-8845-BD4E-CB4CCA059FC4}" type="datetimeFigureOut">
               <a:rPr lang="en-US" smtClean="0"/>
-              <a:t>1/27/13</a:t>
+              <a:t>6/14/2026</a:t>
             </a:fld>
             <a:endParaRPr lang="en-US"/>
           </a:p>
@@ -3083,7 +3078,7 @@
 </file>
 
 <file path=ppt/slides/slide1.xml><?xml version="1.0" encoding="utf-8"?>
-<p:sld xmlns:a="http://schemas.openxmlformats.org/drawingml/2006/main" xmlns:p="http://schemas.openxmlformats.org/presentationml/2006/main" xmlns:r="http://schemas.openxmlformats.org/officeDocument/2006/relationships">
+<p:sld xmlns:a="http://schemas.openxmlformats.org/drawingml/2006/main" xmlns:r="http://schemas.openxmlformats.org/officeDocument/2006/relationships" xmlns:p="http://schemas.openxmlformats.org/presentationml/2006/main">
   <p:cSld>
     <p:bg>
       <p:bgPr>
@@ -3099,7 +3094,14 @@
         <p:cNvGrpSpPr/>
         <p:nvPr/>
       </p:nvGrpSpPr>
-      <p:grpSpPr/>
+      <p:grpSpPr>
+        <a:xfrm>
+          <a:off x="0" y="0"/>
+          <a:ext cx="0" cy="0"/>
+          <a:chOff x="0" y="0"/>
+          <a:chExt cx="0" cy="0"/>
+        </a:xfrm>
+      </p:grpSpPr>
       <p:sp>
         <p:nvSpPr>
           <p:cNvPr id="2" name="TextBox 1"/>
@@ -3117,7 +3119,7 @@
           <a:noFill/>
         </p:spPr>
         <p:txBody>
-          <a:bodyPr wrap="square" lIns="0" rIns="0" tIns="0" bIns="0">
+          <a:bodyPr wrap="square" lIns="0" tIns="0" rIns="0" bIns="0">
             <a:spAutoFit/>
           </a:bodyPr>
           <a:lstStyle/>
@@ -3208,8 +3210,8 @@
         </p:nvSpPr>
         <p:spPr>
           <a:xfrm>
-            <a:off x="8046720" y="1645920"/>
-            <a:ext cx="3383280" cy="4114800"/>
+            <a:off x="7772400" y="1645920"/>
+            <a:ext cx="4156682" cy="4114800"/>
           </a:xfrm>
           <a:prstGeom prst="roundRect">
             <a:avLst/>
@@ -3238,7 +3240,7 @@
           </a:fontRef>
         </p:style>
         <p:txBody>
-          <a:bodyPr rtlCol="0" anchor="ctr" wrap="square" lIns="182880" rIns="182880" tIns="457200" bIns="182880"/>
+          <a:bodyPr wrap="square" lIns="182880" tIns="457200" rIns="182880" bIns="182880" rtlCol="0" anchor="ctr"/>
           <a:lstStyle/>
           <a:p>
             <a:pPr algn="ctr">
@@ -3250,58 +3252,134 @@
               </a:defRPr>
             </a:pPr>
             <a:r>
+              <a:rPr dirty="0"/>
               <a:t>🧭 Triage Agent</a:t>
             </a:r>
-            <a:br/>
-            <a:r>
-              <a:t>      │</a:t>
-            </a:r>
-            <a:br/>
-            <a:r>
+            <a:br>
+              <a:rPr dirty="0"/>
+            </a:br>
+            <a:r>
+              <a:rPr dirty="0"/>
+              <a:t>│</a:t>
+            </a:r>
+            <a:br>
+              <a:rPr lang="en-IN" dirty="0"/>
+            </a:br>
+            <a:r>
+              <a:rPr dirty="0"/>
               <a:t>┌─────┴─────┐</a:t>
             </a:r>
-            <a:br/>
-            <a:r>
+            <a:br>
+              <a:rPr dirty="0"/>
+            </a:br>
+            <a:r>
+              <a:rPr dirty="0"/>
               <a:t>▼     ▼     ▼</a:t>
             </a:r>
-            <a:br/>
-            <a:r>
-              <a:t>💡    💡    💡 (Hypotheses)</a:t>
-            </a:r>
-            <a:br/>
-            <a:r>
+            <a:br>
+              <a:rPr dirty="0"/>
+            </a:br>
+            <a:r>
+              <a:rPr lang="en-US" dirty="0"/>
+              <a:t>         </a:t>
+            </a:r>
+            <a:r>
+              <a:rPr dirty="0"/>
+              <a:t>💡   </a:t>
+            </a:r>
+            <a:r>
+              <a:rPr lang="en-US" dirty="0"/>
+              <a:t> </a:t>
+            </a:r>
+            <a:r>
+              <a:rPr dirty="0"/>
+              <a:t>💡   </a:t>
+            </a:r>
+            <a:r>
+              <a:rPr lang="en-IN" dirty="0"/>
+              <a:t>💡</a:t>
+            </a:r>
+            <a:r>
+              <a:rPr dirty="0"/>
+              <a:t>Hypotheses</a:t>
+            </a:r>
+            <a:br>
+              <a:rPr dirty="0"/>
+            </a:br>
+            <a:r>
+              <a:rPr dirty="0"/>
               <a:t>│     │     │</a:t>
             </a:r>
-            <a:br/>
-            <a:r>
+            <a:br>
+              <a:rPr dirty="0"/>
+            </a:br>
+            <a:r>
+              <a:rPr dirty="0"/>
               <a:t>▼     ▼     ▼</a:t>
             </a:r>
-            <a:br/>
-            <a:r>
-              <a:t>🔍    🔍    🔍 (Evidence)</a:t>
-            </a:r>
-            <a:br/>
-            <a:r>
-              <a:t>└─────┬─────┘</a:t>
-            </a:r>
-            <a:br/>
-            <a:r>
-              <a:t>      ▼</a:t>
-            </a:r>
-            <a:br/>
-            <a:r>
+            <a:br>
+              <a:rPr dirty="0"/>
+            </a:br>
+            <a:r>
+              <a:rPr lang="en-US" dirty="0"/>
+              <a:t>         </a:t>
+            </a:r>
+            <a:r>
+              <a:rPr dirty="0"/>
+              <a:t>🔍    🔍   🔍</a:t>
+            </a:r>
+            <a:r>
+              <a:rPr lang="en-US" dirty="0"/>
+              <a:t> </a:t>
+            </a:r>
+            <a:r>
+              <a:rPr dirty="0"/>
+              <a:t>Evidence</a:t>
+            </a:r>
+            <a:br>
+              <a:rPr dirty="0"/>
+            </a:br>
+            <a:r>
+              <a:rPr dirty="0"/>
+              <a:t>└─────┬─────</a:t>
+            </a:r>
+            <a:r>
+              <a:rPr lang="en-IN" dirty="0"/>
+              <a:t>┘</a:t>
+            </a:r>
+            <a:br>
+              <a:rPr lang="en-IN" dirty="0"/>
+            </a:br>
+            <a:r>
+              <a:rPr dirty="0"/>
+              <a:t>▼</a:t>
+            </a:r>
+            <a:br>
+              <a:rPr dirty="0"/>
+            </a:br>
+            <a:r>
+              <a:rPr dirty="0"/>
               <a:t>⚔️ Critic Agent</a:t>
             </a:r>
-            <a:br/>
-            <a:r>
-              <a:t>      │</a:t>
-            </a:r>
-            <a:br/>
-            <a:r>
-              <a:t>      ▼</a:t>
-            </a:r>
-            <a:br/>
-            <a:r>
+            <a:br>
+              <a:rPr dirty="0"/>
+            </a:br>
+            <a:r>
+              <a:rPr dirty="0"/>
+              <a:t>│</a:t>
+            </a:r>
+            <a:br>
+              <a:rPr lang="en-IN" dirty="0"/>
+            </a:br>
+            <a:r>
+              <a:rPr dirty="0"/>
+              <a:t>▼</a:t>
+            </a:r>
+            <a:br>
+              <a:rPr dirty="0"/>
+            </a:br>
+            <a:r>
+              <a:rPr dirty="0"/>
               <a:t>⚖️ Judge Verdict</a:t>
             </a:r>
           </a:p>
@@ -3316,7 +3394,7 @@
 </file>
 
 <file path=ppt/slides/slide2.xml><?xml version="1.0" encoding="utf-8"?>
-<p:sld xmlns:a="http://schemas.openxmlformats.org/drawingml/2006/main" xmlns:p="http://schemas.openxmlformats.org/presentationml/2006/main" xmlns:r="http://schemas.openxmlformats.org/officeDocument/2006/relationships">
+<p:sld xmlns:a="http://schemas.openxmlformats.org/drawingml/2006/main" xmlns:r="http://schemas.openxmlformats.org/officeDocument/2006/relationships" xmlns:p="http://schemas.openxmlformats.org/presentationml/2006/main">
   <p:cSld>
     <p:bg>
       <p:bgPr>
@@ -3332,7 +3410,14 @@
         <p:cNvGrpSpPr/>
         <p:nvPr/>
       </p:nvGrpSpPr>
-      <p:grpSpPr/>
+      <p:grpSpPr>
+        <a:xfrm>
+          <a:off x="0" y="0"/>
+          <a:ext cx="0" cy="0"/>
+          <a:chOff x="0" y="0"/>
+          <a:chExt cx="0" cy="0"/>
+        </a:xfrm>
+      </p:grpSpPr>
       <p:sp>
         <p:nvSpPr>
           <p:cNvPr id="2" name="TextBox 1"/>
@@ -3350,7 +3435,7 @@
           <a:noFill/>
         </p:spPr>
         <p:txBody>
-          <a:bodyPr wrap="square" lIns="0" rIns="0" tIns="0" bIns="0">
+          <a:bodyPr wrap="square" lIns="0" tIns="0" rIns="0" bIns="0">
             <a:spAutoFit/>
           </a:bodyPr>
           <a:lstStyle/>
@@ -3423,7 +3508,7 @@
           </a:fontRef>
         </p:style>
         <p:txBody>
-          <a:bodyPr rtlCol="0" anchor="ctr" wrap="square" lIns="182880" rIns="182880" tIns="182880" bIns="182880"/>
+          <a:bodyPr wrap="square" lIns="182880" tIns="182880" rIns="182880" bIns="182880" rtlCol="0" anchor="ctr"/>
           <a:lstStyle/>
           <a:p>
             <a:pPr algn="ctr">
@@ -3529,7 +3614,7 @@
           </a:fontRef>
         </p:style>
         <p:txBody>
-          <a:bodyPr rtlCol="0" anchor="ctr" wrap="square" lIns="182880" rIns="182880" tIns="182880" bIns="182880"/>
+          <a:bodyPr wrap="square" lIns="182880" tIns="182880" rIns="182880" bIns="182880" rtlCol="0" anchor="ctr"/>
           <a:lstStyle/>
           <a:p>
             <a:pPr algn="ctr">
@@ -3606,7 +3691,7 @@
 </file>
 
 <file path=ppt/slides/slide3.xml><?xml version="1.0" encoding="utf-8"?>
-<p:sld xmlns:a="http://schemas.openxmlformats.org/drawingml/2006/main" xmlns:p="http://schemas.openxmlformats.org/presentationml/2006/main" xmlns:r="http://schemas.openxmlformats.org/officeDocument/2006/relationships">
+<p:sld xmlns:a="http://schemas.openxmlformats.org/drawingml/2006/main" xmlns:r="http://schemas.openxmlformats.org/officeDocument/2006/relationships" xmlns:p="http://schemas.openxmlformats.org/presentationml/2006/main">
   <p:cSld>
     <p:bg>
       <p:bgPr>
@@ -3622,7 +3707,14 @@
         <p:cNvGrpSpPr/>
         <p:nvPr/>
       </p:nvGrpSpPr>
-      <p:grpSpPr/>
+      <p:grpSpPr>
+        <a:xfrm>
+          <a:off x="0" y="0"/>
+          <a:ext cx="0" cy="0"/>
+          <a:chOff x="0" y="0"/>
+          <a:chExt cx="0" cy="0"/>
+        </a:xfrm>
+      </p:grpSpPr>
       <p:sp>
         <p:nvSpPr>
           <p:cNvPr id="2" name="TextBox 1"/>
@@ -3640,7 +3732,7 @@
           <a:noFill/>
         </p:spPr>
         <p:txBody>
-          <a:bodyPr wrap="square" lIns="0" rIns="0" tIns="0" bIns="0">
+          <a:bodyPr wrap="square" lIns="0" tIns="0" rIns="0" bIns="0">
             <a:spAutoFit/>
           </a:bodyPr>
           <a:lstStyle/>
@@ -3713,7 +3805,7 @@
           </a:fontRef>
         </p:style>
         <p:txBody>
-          <a:bodyPr rtlCol="0" anchor="ctr" wrap="square" lIns="182880" rIns="182880" tIns="182880" bIns="182880"/>
+          <a:bodyPr wrap="square" lIns="182880" tIns="182880" rIns="182880" bIns="182880" rtlCol="0" anchor="ctr"/>
           <a:lstStyle/>
           <a:p>
             <a:pPr algn="ctr">
@@ -3779,7 +3871,7 @@
           <a:noFill/>
         </p:spPr>
         <p:txBody>
-          <a:bodyPr wrap="none" lIns="0" rIns="0" tIns="0" bIns="0">
+          <a:bodyPr wrap="none" lIns="0" tIns="0" rIns="0" bIns="0">
             <a:spAutoFit/>
           </a:bodyPr>
           <a:lstStyle/>
@@ -3836,7 +3928,7 @@
           </a:fontRef>
         </p:style>
         <p:txBody>
-          <a:bodyPr rtlCol="0" anchor="ctr" wrap="square" lIns="182880" rIns="182880" tIns="182880" bIns="182880"/>
+          <a:bodyPr wrap="square" lIns="182880" tIns="182880" rIns="182880" bIns="182880" rtlCol="0" anchor="ctr"/>
           <a:lstStyle/>
           <a:p>
             <a:pPr algn="ctr">
@@ -3902,7 +3994,7 @@
           <a:noFill/>
         </p:spPr>
         <p:txBody>
-          <a:bodyPr wrap="none" lIns="0" rIns="0" tIns="0" bIns="0">
+          <a:bodyPr wrap="none" lIns="0" tIns="0" rIns="0" bIns="0">
             <a:spAutoFit/>
           </a:bodyPr>
           <a:lstStyle/>
@@ -3959,7 +4051,7 @@
           </a:fontRef>
         </p:style>
         <p:txBody>
-          <a:bodyPr rtlCol="0" anchor="ctr" wrap="square" lIns="182880" rIns="182880" tIns="182880" bIns="182880"/>
+          <a:bodyPr wrap="square" lIns="182880" tIns="182880" rIns="182880" bIns="182880" rtlCol="0" anchor="ctr"/>
           <a:lstStyle/>
           <a:p>
             <a:pPr algn="ctr">
@@ -4025,7 +4117,7 @@
           <a:noFill/>
         </p:spPr>
         <p:txBody>
-          <a:bodyPr wrap="none" lIns="0" rIns="0" tIns="0" bIns="0">
+          <a:bodyPr wrap="none" lIns="0" tIns="0" rIns="0" bIns="0">
             <a:spAutoFit/>
           </a:bodyPr>
           <a:lstStyle/>
@@ -4082,7 +4174,7 @@
           </a:fontRef>
         </p:style>
         <p:txBody>
-          <a:bodyPr rtlCol="0" anchor="ctr" wrap="square" lIns="182880" rIns="182880" tIns="182880" bIns="182880"/>
+          <a:bodyPr wrap="square" lIns="182880" tIns="182880" rIns="182880" bIns="182880" rtlCol="0" anchor="ctr"/>
           <a:lstStyle/>
           <a:p>
             <a:pPr algn="ctr">
@@ -4148,7 +4240,7 @@
           <a:noFill/>
         </p:spPr>
         <p:txBody>
-          <a:bodyPr wrap="none" lIns="0" rIns="0" tIns="0" bIns="0">
+          <a:bodyPr wrap="none" lIns="0" tIns="0" rIns="0" bIns="0">
             <a:spAutoFit/>
           </a:bodyPr>
           <a:lstStyle/>
@@ -4205,7 +4297,7 @@
           </a:fontRef>
         </p:style>
         <p:txBody>
-          <a:bodyPr rtlCol="0" anchor="ctr" wrap="square" lIns="182880" rIns="182880" tIns="182880" bIns="182880"/>
+          <a:bodyPr wrap="square" lIns="182880" tIns="182880" rIns="182880" bIns="182880" rtlCol="0" anchor="ctr"/>
           <a:lstStyle/>
           <a:p>
             <a:pPr algn="ctr">
@@ -4263,7 +4355,7 @@
 </file>
 
 <file path=ppt/slides/slide4.xml><?xml version="1.0" encoding="utf-8"?>
-<p:sld xmlns:a="http://schemas.openxmlformats.org/drawingml/2006/main" xmlns:p="http://schemas.openxmlformats.org/presentationml/2006/main" xmlns:r="http://schemas.openxmlformats.org/officeDocument/2006/relationships">
+<p:sld xmlns:a="http://schemas.openxmlformats.org/drawingml/2006/main" xmlns:r="http://schemas.openxmlformats.org/officeDocument/2006/relationships" xmlns:p="http://schemas.openxmlformats.org/presentationml/2006/main">
   <p:cSld>
     <p:bg>
       <p:bgPr>
@@ -4279,7 +4371,14 @@
         <p:cNvGrpSpPr/>
         <p:nvPr/>
       </p:nvGrpSpPr>
-      <p:grpSpPr/>
+      <p:grpSpPr>
+        <a:xfrm>
+          <a:off x="0" y="0"/>
+          <a:ext cx="0" cy="0"/>
+          <a:chOff x="0" y="0"/>
+          <a:chExt cx="0" cy="0"/>
+        </a:xfrm>
+      </p:grpSpPr>
       <p:sp>
         <p:nvSpPr>
           <p:cNvPr id="2" name="TextBox 1"/>
@@ -4297,7 +4396,7 @@
           <a:noFill/>
         </p:spPr>
         <p:txBody>
-          <a:bodyPr wrap="square" lIns="0" rIns="0" tIns="0" bIns="0">
+          <a:bodyPr wrap="square" lIns="0" tIns="0" rIns="0" bIns="0">
             <a:spAutoFit/>
           </a:bodyPr>
           <a:lstStyle/>
@@ -4370,7 +4469,7 @@
           </a:fontRef>
         </p:style>
         <p:txBody>
-          <a:bodyPr rtlCol="0" anchor="ctr" wrap="square" lIns="182880" rIns="182880" tIns="182880" bIns="182880"/>
+          <a:bodyPr wrap="square" lIns="182880" tIns="182880" rIns="182880" bIns="182880" rtlCol="0" anchor="ctr"/>
           <a:lstStyle/>
           <a:p>
             <a:pPr algn="ctr">
@@ -4444,7 +4543,7 @@
           </a:fontRef>
         </p:style>
         <p:txBody>
-          <a:bodyPr rtlCol="0" anchor="ctr" wrap="square" lIns="182880" rIns="182880" tIns="182880" bIns="182880"/>
+          <a:bodyPr wrap="square" lIns="182880" tIns="182880" rIns="182880" bIns="182880" rtlCol="0" anchor="ctr"/>
           <a:lstStyle/>
           <a:p>
             <a:pPr algn="ctr">
@@ -4518,7 +4617,7 @@
           </a:fontRef>
         </p:style>
         <p:txBody>
-          <a:bodyPr rtlCol="0" anchor="ctr" wrap="square" lIns="182880" rIns="182880" tIns="182880" bIns="182880"/>
+          <a:bodyPr wrap="square" lIns="182880" tIns="182880" rIns="182880" bIns="182880" rtlCol="0" anchor="ctr"/>
           <a:lstStyle/>
           <a:p>
             <a:pPr algn="ctr">
@@ -4592,7 +4691,7 @@
           </a:fontRef>
         </p:style>
         <p:txBody>
-          <a:bodyPr rtlCol="0" anchor="ctr" wrap="square" lIns="182880" rIns="182880" tIns="182880" bIns="182880"/>
+          <a:bodyPr wrap="square" lIns="182880" tIns="182880" rIns="182880" bIns="182880" rtlCol="0" anchor="ctr"/>
           <a:lstStyle/>
           <a:p>
             <a:pPr algn="ctr">
@@ -4637,7 +4736,7 @@
 </file>
 
 <file path=ppt/slides/slide5.xml><?xml version="1.0" encoding="utf-8"?>
-<p:sld xmlns:a="http://schemas.openxmlformats.org/drawingml/2006/main" xmlns:p="http://schemas.openxmlformats.org/presentationml/2006/main" xmlns:r="http://schemas.openxmlformats.org/officeDocument/2006/relationships">
+<p:sld xmlns:a="http://schemas.openxmlformats.org/drawingml/2006/main" xmlns:r="http://schemas.openxmlformats.org/officeDocument/2006/relationships" xmlns:p="http://schemas.openxmlformats.org/presentationml/2006/main">
   <p:cSld>
     <p:bg>
       <p:bgPr>
@@ -4653,7 +4752,14 @@
         <p:cNvGrpSpPr/>
         <p:nvPr/>
       </p:nvGrpSpPr>
-      <p:grpSpPr/>
+      <p:grpSpPr>
+        <a:xfrm>
+          <a:off x="0" y="0"/>
+          <a:ext cx="0" cy="0"/>
+          <a:chOff x="0" y="0"/>
+          <a:chExt cx="0" cy="0"/>
+        </a:xfrm>
+      </p:grpSpPr>
       <p:sp>
         <p:nvSpPr>
           <p:cNvPr id="2" name="TextBox 1"/>
@@ -4671,7 +4777,7 @@
           <a:noFill/>
         </p:spPr>
         <p:txBody>
-          <a:bodyPr wrap="square" lIns="0" rIns="0" tIns="0" bIns="0">
+          <a:bodyPr wrap="square" lIns="0" tIns="0" rIns="0" bIns="0">
             <a:spAutoFit/>
           </a:bodyPr>
           <a:lstStyle/>
@@ -4744,7 +4850,7 @@
           </a:fontRef>
         </p:style>
         <p:txBody>
-          <a:bodyPr rtlCol="0" anchor="ctr" wrap="square" lIns="182880" rIns="182880" tIns="182880" bIns="182880"/>
+          <a:bodyPr wrap="square" lIns="182880" tIns="182880" rIns="182880" bIns="182880" rtlCol="0" anchor="ctr"/>
           <a:lstStyle/>
           <a:p>
             <a:pPr algn="ctr">
@@ -4759,6 +4865,7 @@
               </a:defRPr>
             </a:pPr>
             <a:r>
+              <a:rPr dirty="0"/>
               <a:t>🎯  Built-in Incident: INC-4821</a:t>
             </a:r>
           </a:p>
@@ -4775,6 +4882,7 @@
               </a:defRPr>
             </a:pPr>
             <a:r>
+              <a:rPr dirty="0"/>
               <a:t>Includes realistic test cases to demonstrate Swarm reasoning:</a:t>
             </a:r>
           </a:p>
@@ -4791,6 +4899,7 @@
               </a:defRPr>
             </a:pPr>
             <a:r>
+              <a:rPr dirty="0"/>
               <a:t>✔  Outage Symptom: Latency spike and elevated 500 errors on checkout service.</a:t>
             </a:r>
           </a:p>
@@ -4807,6 +4916,7 @@
               </a:defRPr>
             </a:pPr>
             <a:r>
+              <a:rPr dirty="0"/>
               <a:t>✔  Root Cause: A database deployment changes max connections from 50 to 10.</a:t>
             </a:r>
           </a:p>
@@ -4823,6 +4933,7 @@
               </a:defRPr>
             </a:pPr>
             <a:r>
+              <a:rPr dirty="0"/>
               <a:t>✔  Red Herrings: Placed fake Redis key-eviction logs and payment gateway gateway-timeout warnings.</a:t>
             </a:r>
           </a:p>
@@ -4839,7 +4950,16 @@
               </a:defRPr>
             </a:pPr>
             <a:r>
-              <a:t>✔  Outcome: SentrySwarm's Critic successfully rejects the red herrings, and the Judge pinpoints connection-pool exhaustion.</a:t>
+              <a:rPr dirty="0"/>
+              <a:t>✔  Outcome: </a:t>
+            </a:r>
+            <a:r>
+              <a:rPr dirty="0" err="1"/>
+              <a:t>SentrySwarm's</a:t>
+            </a:r>
+            <a:r>
+              <a:rPr dirty="0"/>
+              <a:t> Critic successfully rejects the red herrings, and the Judge pinpoints connection-pool exhaustion.</a:t>
             </a:r>
           </a:p>
         </p:txBody>
@@ -4882,7 +5002,7 @@
           </a:fontRef>
         </p:style>
         <p:txBody>
-          <a:bodyPr rtlCol="0" anchor="ctr" wrap="square" lIns="182880" rIns="182880" tIns="182880" bIns="182880"/>
+          <a:bodyPr wrap="square" lIns="182880" tIns="182880" rIns="182880" bIns="182880" rtlCol="0" anchor="ctr"/>
           <a:lstStyle/>
           <a:p>
             <a:pPr algn="ctr">

</xml_diff>